<commit_message>
Add Folder Thread Intel, kelupaan
</commit_message>
<xml_diff>
--- a/windows-x64/detect-eng-technical-test-windows-x64/threat-intel/Airlangga_ThreatIntel_Report_March2026.pptx
+++ b/windows-x64/detect-eng-technical-test-windows-x64/threat-intel/Airlangga_ThreatIntel_Report_March2026.pptx
@@ -12,6 +12,8 @@
     <p:sldId id="260" r:id="rId11"/>
     <p:sldId id="261" r:id="rId12"/>
     <p:sldId id="262" r:id="rId13"/>
+    <p:sldId id="263" r:id="rId14"/>
+    <p:sldId id="264" r:id="rId15"/>
   </p:sldIdLst>
   <p:sldSz cx="9144000" cy="6858000" type="screen4x3"/>
   <p:notesSz cx="6858000" cy="9144000"/>
@@ -3134,6 +3136,12 @@
               <a:t>Analysis based on MISP blocklist feeds (URLHaus, OpenPhish, Tor)</a:t>
             </a:r>
           </a:p>
+          <a:p/>
+          <a:p>
+            <a:r>
+              <a:t>This report represents a snapshot of threat activity during the ingestion period (March–April 2026).</a:t>
+            </a:r>
+          </a:p>
         </p:txBody>
       </p:sp>
     </p:spTree>
@@ -3170,7 +3178,7 @@
           <a:lstStyle/>
           <a:p>
             <a:r>
-              <a:t>Data Source</a:t>
+              <a:t>Data Sources &amp; Justification</a:t>
             </a:r>
           </a:p>
         </p:txBody>
@@ -3191,28 +3199,23 @@
           <a:lstStyle/>
           <a:p>
             <a:r>
-              <a:t>Feeds used:</a:t>
-            </a:r>
-          </a:p>
-          <a:p>
-            <a:r>
-              <a:t>- URLHaus</a:t>
-            </a:r>
-          </a:p>
-          <a:p>
-            <a:r>
-              <a:t>- OpenPhish</a:t>
-            </a:r>
-          </a:p>
-          <a:p>
-            <a:r>
-              <a:t>- Tor Exit Nodes</a:t>
+              <a:t>URLHaus → Malware distribution</a:t>
+            </a:r>
+          </a:p>
+          <a:p>
+            <a:r>
+              <a:t>OpenPhish → Phishing infrastructure</a:t>
+            </a:r>
+          </a:p>
+          <a:p>
+            <a:r>
+              <a:t>Tor Exit Nodes → Anonymization</a:t>
             </a:r>
           </a:p>
           <a:p/>
           <a:p>
             <a:r>
-              <a:t>Blocklist-based snapshot analysis</a:t>
+              <a:t>Blocklist-based feeds analyzed for pattern detection and IOC clustering.</a:t>
             </a:r>
           </a:p>
         </p:txBody>
@@ -3251,7 +3254,7 @@
           <a:lstStyle/>
           <a:p>
             <a:r>
-              <a:t>Key Indicators</a:t>
+              <a:t>Key Indicators (Sample)</a:t>
             </a:r>
           </a:p>
         </p:txBody>
@@ -3272,27 +3275,27 @@
           <a:lstStyle/>
           <a:p>
             <a:r>
-              <a:t>http://customer-support-system-client-solution-center.pages.dev/appeal_form</a:t>
-            </a:r>
-          </a:p>
-          <a:p>
-            <a:r>
-              <a:t>http://instagramusicabrasilinstagram.blogspot.com/</a:t>
-            </a:r>
-          </a:p>
-          <a:p>
-            <a:r>
-              <a:t>https://ipfs.io/ipfs/bafkreief4lkykm4ijpuet3a4hpuvv735zb2begoy3guq4bklnedstoztxm</a:t>
-            </a:r>
-          </a:p>
-          <a:p>
-            <a:r>
-              <a:t>http://learn-trezr-suite.vercel.app/</a:t>
-            </a:r>
-          </a:p>
-          <a:p>
-            <a:r>
-              <a:t>https://data-daceme.help-rich.com/</a:t>
+              <a:t>customer-support-system-client-solution-center.pages.dev</a:t>
+            </a:r>
+          </a:p>
+          <a:p>
+            <a:r>
+              <a:t>instagramusicabrasilinstagram.blogspot.com</a:t>
+            </a:r>
+          </a:p>
+          <a:p>
+            <a:r>
+              <a:t>ipfs.io/ipfs/...</a:t>
+            </a:r>
+          </a:p>
+          <a:p>
+            <a:r>
+              <a:t>learn-trezr-suite.vercel.app</a:t>
+            </a:r>
+          </a:p>
+          <a:p>
+            <a:r>
+              <a:t>help-rich.com</a:t>
             </a:r>
           </a:p>
         </p:txBody>
@@ -3331,7 +3334,7 @@
           <a:lstStyle/>
           <a:p>
             <a:r>
-              <a:t>Attack Patterns</a:t>
+              <a:t>Top Domains Observed</a:t>
             </a:r>
           </a:p>
         </p:txBody>
@@ -3352,27 +3355,22 @@
           <a:lstStyle/>
           <a:p>
             <a:r>
-              <a:t>Pattern</a:t>
-            </a:r>
-          </a:p>
-          <a:p>
-            <a:r>
-              <a:t>Scanner/High Port    23299</a:t>
-            </a:r>
-          </a:p>
-          <a:p>
-            <a:r>
-              <a:t>Malware Dropper       4558</a:t>
-            </a:r>
-          </a:p>
-          <a:p>
-            <a:r>
-              <a:t>Other                 2150</a:t>
-            </a:r>
-          </a:p>
-          <a:p>
-            <a:r>
-              <a:t>Suspicious TLD         267</a:t>
+              <a:t>refundonex.com (dominant)</a:t>
+            </a:r>
+          </a:p>
+          <a:p>
+            <a:r>
+              <a:t>103.130.214.71:4949 (scanner)</a:t>
+            </a:r>
+          </a:p>
+          <a:p>
+            <a:r>
+              <a:t>github.com / raw.githubusercontent.com (abused hosting)</a:t>
+            </a:r>
+          </a:p>
+          <a:p>
+            <a:r>
+              <a:t>89.144.31.35</a:t>
             </a:r>
           </a:p>
         </p:txBody>
@@ -3411,7 +3409,7 @@
           <a:lstStyle/>
           <a:p>
             <a:r>
-              <a:t>Top Domains</a:t>
+              <a:t>Attack Patterns Distribution</a:t>
             </a:r>
           </a:p>
         </p:txBody>
@@ -3432,32 +3430,22 @@
           <a:lstStyle/>
           <a:p>
             <a:r>
-              <a:t>Domain</a:t>
-            </a:r>
-          </a:p>
-          <a:p>
-            <a:r>
-              <a:t>refundonex.com               2841</a:t>
-            </a:r>
-          </a:p>
-          <a:p>
-            <a:r>
-              <a:t>103.130.214.71:4949           822</a:t>
-            </a:r>
-          </a:p>
-          <a:p>
-            <a:r>
-              <a:t>github.com                    633</a:t>
-            </a:r>
-          </a:p>
-          <a:p>
-            <a:r>
-              <a:t>raw.githubusercontent.com     524</a:t>
-            </a:r>
-          </a:p>
-          <a:p>
-            <a:r>
-              <a:t>89.144.31.35                  154</a:t>
+              <a:t>Scanner / High Port → dominant (bot-like behavior)</a:t>
+            </a:r>
+          </a:p>
+          <a:p>
+            <a:r>
+              <a:t>Malware Dropper (/bin.sh)</a:t>
+            </a:r>
+          </a:p>
+          <a:p>
+            <a:r>
+              <a:t>Suspicious TLD usage (.bet)</a:t>
+            </a:r>
+          </a:p>
+          <a:p>
+            <a:r>
+              <a:t>Other noise indicators</a:t>
             </a:r>
           </a:p>
         </p:txBody>
@@ -3496,7 +3484,7 @@
           <a:lstStyle/>
           <a:p>
             <a:r>
-              <a:t>Analysis</a:t>
+              <a:t>Key Observations</a:t>
             </a:r>
           </a:p>
         </p:txBody>
@@ -3517,7 +3505,22 @@
           <a:lstStyle/>
           <a:p>
             <a:r>
-              <a:t>Patterns indicate malware distribution (/bin.sh), suspicious TLD abuse (.bet), and scanning activity.</a:t>
+              <a:t>• High volume scanning indicates automated botnet activity</a:t>
+            </a:r>
+          </a:p>
+          <a:p>
+            <a:r>
+              <a:t>• Use of public hosting (GitHub, IPFS) suggests payload delivery evasion</a:t>
+            </a:r>
+          </a:p>
+          <a:p>
+            <a:r>
+              <a:t>• Repeated domain usage indicates infrastructure reuse</a:t>
+            </a:r>
+          </a:p>
+          <a:p>
+            <a:r>
+              <a:t>• Suspicious TLD (.bet) likely abused for low-cost malicious hosting</a:t>
             </a:r>
           </a:p>
         </p:txBody>
@@ -3556,6 +3559,87 @@
           <a:lstStyle/>
           <a:p>
             <a:r>
+              <a:t>Threat Analysis</a:t>
+            </a:r>
+          </a:p>
+        </p:txBody>
+      </p:sp>
+      <p:sp>
+        <p:nvSpPr>
+          <p:cNvPr id="3" name="Content Placeholder 2"/>
+          <p:cNvSpPr>
+            <a:spLocks noGrp="1"/>
+          </p:cNvSpPr>
+          <p:nvPr>
+            <p:ph idx="1"/>
+          </p:nvPr>
+        </p:nvSpPr>
+        <p:spPr/>
+        <p:txBody>
+          <a:bodyPr/>
+          <a:lstStyle/>
+          <a:p>
+            <a:r>
+              <a:t>Observed activity suggests coordinated campaigns combining:</a:t>
+            </a:r>
+          </a:p>
+          <a:p>
+            <a:r>
+              <a:t>- Malware delivery</a:t>
+            </a:r>
+          </a:p>
+          <a:p>
+            <a:r>
+              <a:t>- Phishing infrastructure</a:t>
+            </a:r>
+          </a:p>
+          <a:p>
+            <a:r>
+              <a:t>- Automated scanning</a:t>
+            </a:r>
+          </a:p>
+          <a:p/>
+          <a:p>
+            <a:r>
+              <a:t>Likely part of distributed opportunistic attack ecosystem.</a:t>
+            </a:r>
+          </a:p>
+        </p:txBody>
+      </p:sp>
+    </p:spTree>
+  </p:cSld>
+  <p:clrMapOvr>
+    <a:masterClrMapping/>
+  </p:clrMapOvr>
+</p:sld>
+</file>
+
+<file path=ppt/slides/slide8.xml><?xml version="1.0" encoding="utf-8"?>
+<p:sld xmlns:a="http://schemas.openxmlformats.org/drawingml/2006/main" xmlns:p="http://schemas.openxmlformats.org/presentationml/2006/main" xmlns:r="http://schemas.openxmlformats.org/officeDocument/2006/relationships">
+  <p:cSld>
+    <p:spTree>
+      <p:nvGrpSpPr>
+        <p:cNvPr id="1" name=""/>
+        <p:cNvGrpSpPr/>
+        <p:nvPr/>
+      </p:nvGrpSpPr>
+      <p:grpSpPr/>
+      <p:sp>
+        <p:nvSpPr>
+          <p:cNvPr id="2" name="Title 1"/>
+          <p:cNvSpPr>
+            <a:spLocks noGrp="1"/>
+          </p:cNvSpPr>
+          <p:nvPr>
+            <p:ph type="title"/>
+          </p:nvPr>
+        </p:nvSpPr>
+        <p:spPr/>
+        <p:txBody>
+          <a:bodyPr/>
+          <a:lstStyle/>
+          <a:p>
+            <a:r>
               <a:t>Recommendations</a:t>
             </a:r>
           </a:p>
@@ -3577,22 +3661,115 @@
           <a:lstStyle/>
           <a:p>
             <a:r>
-              <a:t>- Block suspicious domains</a:t>
-            </a:r>
-          </a:p>
-          <a:p>
-            <a:r>
-              <a:t>- Detect /bin.sh downloads</a:t>
-            </a:r>
-          </a:p>
-          <a:p>
-            <a:r>
-              <a:t>- Monitor outbound traffic</a:t>
-            </a:r>
-          </a:p>
-          <a:p>
-            <a:r>
-              <a:t>- Enrich SIEM with IOC feeds</a:t>
+              <a:t>Detection:</a:t>
+            </a:r>
+          </a:p>
+          <a:p>
+            <a:r>
+              <a:t>- Alert on /bin.sh downloads</a:t>
+            </a:r>
+          </a:p>
+          <a:p>
+            <a:r>
+              <a:t>- Detect outbound connections to high ports</a:t>
+            </a:r>
+          </a:p>
+          <a:p/>
+          <a:p>
+            <a:r>
+              <a:t>Prevention:</a:t>
+            </a:r>
+          </a:p>
+          <a:p>
+            <a:r>
+              <a:t>- Block suspicious TLD (.bet)</a:t>
+            </a:r>
+          </a:p>
+          <a:p>
+            <a:r>
+              <a:t>- Restrict unknown domains</a:t>
+            </a:r>
+          </a:p>
+          <a:p/>
+          <a:p>
+            <a:r>
+              <a:t>Monitoring:</a:t>
+            </a:r>
+          </a:p>
+          <a:p>
+            <a:r>
+              <a:t>- Track IOC correlation in SIEM</a:t>
+            </a:r>
+          </a:p>
+          <a:p>
+            <a:r>
+              <a:t>- Enrich logs with threat intel feeds</a:t>
+            </a:r>
+          </a:p>
+        </p:txBody>
+      </p:sp>
+    </p:spTree>
+  </p:cSld>
+  <p:clrMapOvr>
+    <a:masterClrMapping/>
+  </p:clrMapOvr>
+</p:sld>
+</file>
+
+<file path=ppt/slides/slide9.xml><?xml version="1.0" encoding="utf-8"?>
+<p:sld xmlns:a="http://schemas.openxmlformats.org/drawingml/2006/main" xmlns:p="http://schemas.openxmlformats.org/presentationml/2006/main" xmlns:r="http://schemas.openxmlformats.org/officeDocument/2006/relationships">
+  <p:cSld>
+    <p:spTree>
+      <p:nvGrpSpPr>
+        <p:cNvPr id="1" name=""/>
+        <p:cNvGrpSpPr/>
+        <p:nvPr/>
+      </p:nvGrpSpPr>
+      <p:grpSpPr/>
+      <p:sp>
+        <p:nvSpPr>
+          <p:cNvPr id="2" name="Title 1"/>
+          <p:cNvSpPr>
+            <a:spLocks noGrp="1"/>
+          </p:cNvSpPr>
+          <p:nvPr>
+            <p:ph type="title"/>
+          </p:nvPr>
+        </p:nvSpPr>
+        <p:spPr/>
+        <p:txBody>
+          <a:bodyPr/>
+          <a:lstStyle/>
+          <a:p>
+            <a:r>
+              <a:t>Conclusion</a:t>
+            </a:r>
+          </a:p>
+        </p:txBody>
+      </p:sp>
+      <p:sp>
+        <p:nvSpPr>
+          <p:cNvPr id="3" name="Content Placeholder 2"/>
+          <p:cNvSpPr>
+            <a:spLocks noGrp="1"/>
+          </p:cNvSpPr>
+          <p:nvPr>
+            <p:ph idx="1"/>
+          </p:nvPr>
+        </p:nvSpPr>
+        <p:spPr/>
+        <p:txBody>
+          <a:bodyPr/>
+          <a:lstStyle/>
+          <a:p>
+            <a:r>
+              <a:t>Despite blocklist-based feeds, meaningful threat patterns were identified.</a:t>
+            </a:r>
+          </a:p>
+          <a:p/>
+          <a:p>
+            <a:r>
+              <a:t>Findings support improved detection, monitoring, and proactive defense strategies.</a:t>
             </a:r>
           </a:p>
         </p:txBody>

</xml_diff>